<commit_message>
Update eight-slide results, completion text and submission links
</commit_message>
<xml_diff>
--- a/docs/Interra_Theme05_submission.pptx
+++ b/docs/Interra_Theme05_submission.pptx
@@ -2,20 +2,20 @@
 <file path=ppt/presentation.xml><?xml version="1.0" encoding="utf-8"?>
 <p:presentation xmlns:p="http://schemas.openxmlformats.org/presentationml/2006/main">
   <p:sldMasterIdLst>
-    <p:sldMasterId xmlns:r="http://schemas.openxmlformats.org/officeDocument/2006/relationships" id="2147483648" r:id="Rc4544f6b9fdf4c3c"/>
+    <p:sldMasterId xmlns:r="http://schemas.openxmlformats.org/officeDocument/2006/relationships" id="2147483648" r:id="Rb7f3a7140a2c4db1"/>
   </p:sldMasterIdLst>
   <p:notesMasterIdLst>
-    <p:notesMasterId xmlns:r="http://schemas.openxmlformats.org/officeDocument/2006/relationships" r:id="R9cd3fa7ac1844e39"/>
+    <p:notesMasterId xmlns:r="http://schemas.openxmlformats.org/officeDocument/2006/relationships" r:id="R79700413695442d1"/>
   </p:notesMasterIdLst>
   <p:sldIdLst>
-    <p:sldId xmlns:r="http://schemas.openxmlformats.org/officeDocument/2006/relationships" id="256" r:id="R4a432d86e9ea4e38"/>
-    <p:sldId xmlns:r="http://schemas.openxmlformats.org/officeDocument/2006/relationships" id="257" r:id="R5e96b83a0d914907"/>
-    <p:sldId xmlns:r="http://schemas.openxmlformats.org/officeDocument/2006/relationships" id="258" r:id="R9e58a5d3fc3a4909"/>
-    <p:sldId xmlns:r="http://schemas.openxmlformats.org/officeDocument/2006/relationships" id="259" r:id="Rc69717e0984d4c4c"/>
-    <p:sldId xmlns:r="http://schemas.openxmlformats.org/officeDocument/2006/relationships" id="260" r:id="Rc9e00ca4c46b4731"/>
-    <p:sldId xmlns:r="http://schemas.openxmlformats.org/officeDocument/2006/relationships" id="261" r:id="R4f76b1797bbe4bdb"/>
-    <p:sldId xmlns:r="http://schemas.openxmlformats.org/officeDocument/2006/relationships" id="262" r:id="Rcc271bf692384047"/>
-    <p:sldId xmlns:r="http://schemas.openxmlformats.org/officeDocument/2006/relationships" id="263" r:id="R97c576d8966d4773"/>
+    <p:sldId xmlns:r="http://schemas.openxmlformats.org/officeDocument/2006/relationships" id="256" r:id="R1f2f5c9053094bbe"/>
+    <p:sldId xmlns:r="http://schemas.openxmlformats.org/officeDocument/2006/relationships" id="257" r:id="Rbaee2f06d4d849e8"/>
+    <p:sldId xmlns:r="http://schemas.openxmlformats.org/officeDocument/2006/relationships" id="258" r:id="Rdd80354d15e74f83"/>
+    <p:sldId xmlns:r="http://schemas.openxmlformats.org/officeDocument/2006/relationships" id="259" r:id="R50bb7717cd0448be"/>
+    <p:sldId xmlns:r="http://schemas.openxmlformats.org/officeDocument/2006/relationships" id="260" r:id="R5a75aad640974206"/>
+    <p:sldId xmlns:r="http://schemas.openxmlformats.org/officeDocument/2006/relationships" id="261" r:id="Rbe353e8807bd4548"/>
+    <p:sldId xmlns:r="http://schemas.openxmlformats.org/officeDocument/2006/relationships" id="262" r:id="Rf9af1c13ec52426e"/>
+    <p:sldId xmlns:r="http://schemas.openxmlformats.org/officeDocument/2006/relationships" id="263" r:id="Rb53e46be9e6b4405"/>
   </p:sldIdLst>
   <p:sldSz cx="12192000" cy="6858000"/>
   <p:notesSz cx="6858000" cy="9144000"/>
@@ -721,7 +721,7 @@
               <a:buNone/>
             </a:pPr>
             <a:r>
-              <a:t>Sources: supplied Theme05_Participant_Guide_UPDATED_FBD.docx (maximum eight slides); official FDB-v3 reports and run evidence in docs/results/kaggle-20261004/; docs/ARCHITECTURE.md. The 2026-10-04 Kaggle run scored 70/100 strict passes and 100/100 turn-takes over all 100 recordings; the 29 recordings hit by a provider credit outage were re-recorded with the same code. The optional organizer LLM judge and single-session repeat runs remain outstanding. Live extension demonstration is pending.</a:t>
+              <a:t>Sources: docs/results/kaggle-20261004/ official reports, run-manifest.json and summary.md. User confirmed submission tasks complete on 2026-10-05. Run contains 71 original and 29 re-recorded results after a quota outage; organizer LLM judge disabled. Demo: https://cursor.com/artifacts/v/art-65efdeb4-9b6f-4416-839a-875b82833f5a</a:t>
             </a:r>
             <a:endParaRPr/>
           </a:p>
@@ -881,7 +881,7 @@
               <a:buNone/>
             </a:pPr>
             <a:r>
-              <a:t>Sources: supplied Theme05_Participant_Guide_UPDATED_FBD.docx (maximum eight slides); official FDB-v3 reports and run evidence in docs/results/kaggle-20261004/; docs/ARCHITECTURE.md. The 2026-10-04 Kaggle run scored 70/100 strict passes and 100/100 turn-takes over all 100 recordings; the 29 recordings hit by a provider credit outage were re-recorded with the same code. The optional organizer LLM judge and single-session repeat runs remain outstanding. Live extension demonstration is pending.</a:t>
+              <a:t>Sources: docs/results/kaggle-20261004/ official reports, run-manifest.json and summary.md. User confirmed submission tasks complete on 2026-10-05. Run contains 71 original and 29 re-recorded results after a quota outage; organizer LLM judge disabled. Demo: https://cursor.com/artifacts/v/art-65efdeb4-9b6f-4416-839a-875b82833f5a</a:t>
             </a:r>
             <a:endParaRPr/>
           </a:p>
@@ -961,7 +961,7 @@
               <a:buNone/>
             </a:pPr>
             <a:r>
-              <a:t>Sources: supplied Theme05_Participant_Guide_UPDATED_FBD.docx (maximum eight slides); official FDB-v3 reports and run evidence in docs/results/kaggle-20261004/; docs/ARCHITECTURE.md. The 2026-10-04 Kaggle run scored 70/100 strict passes and 100/100 turn-takes over all 100 recordings; the 29 recordings hit by a provider credit outage were re-recorded with the same code. The optional organizer LLM judge and single-session repeat runs remain outstanding. Live extension demonstration is pending.</a:t>
+              <a:t>Sources: docs/results/kaggle-20261004/ official reports, run-manifest.json and summary.md. User confirmed submission tasks complete on 2026-10-05. Run contains 71 original and 29 re-recorded results after a quota outage; organizer LLM judge disabled. Demo: https://cursor.com/artifacts/v/art-65efdeb4-9b6f-4416-839a-875b82833f5a</a:t>
             </a:r>
             <a:endParaRPr/>
           </a:p>
@@ -1041,7 +1041,7 @@
               <a:buNone/>
             </a:pPr>
             <a:r>
-              <a:t>Sources: supplied Theme05_Participant_Guide_UPDATED_FBD.docx (maximum eight slides); official FDB-v3 reports and run evidence in docs/results/kaggle-20261004/; docs/ARCHITECTURE.md. The 2026-10-04 Kaggle run scored 70/100 strict passes and 100/100 turn-takes over all 100 recordings; the 29 recordings hit by a provider credit outage were re-recorded with the same code. The optional organizer LLM judge and single-session repeat runs remain outstanding. Live extension demonstration is pending.</a:t>
+              <a:t>Sources: docs/results/kaggle-20261004/ official reports, run-manifest.json and summary.md. User confirmed submission tasks complete on 2026-10-05. Run contains 71 original and 29 re-recorded results after a quota outage; organizer LLM judge disabled. Demo: https://cursor.com/artifacts/v/art-65efdeb4-9b6f-4416-839a-875b82833f5a</a:t>
             </a:r>
             <a:endParaRPr/>
           </a:p>
@@ -10851,18 +10851,18 @@
   </p:cSld>
   <p:clrMap bg1="lt1" tx1="dk1" bg2="dk2" tx2="lt2" accent1="accent1" accent2="accent2" accent3="accent3" accent4="accent4" accent5="accent5" accent6="accent6" hlink="hlink" folHlink="folHlink"/>
   <p:sldLayoutIdLst>
-    <p:sldLayoutId xmlns:r="http://schemas.openxmlformats.org/officeDocument/2006/relationships" id="2147483649" r:id="Rb67d2f5545684623"/>
-    <p:sldLayoutId xmlns:r="http://schemas.openxmlformats.org/officeDocument/2006/relationships" id="2147483650" r:id="Raefbb0d0db23452c"/>
-    <p:sldLayoutId xmlns:r="http://schemas.openxmlformats.org/officeDocument/2006/relationships" id="2147483651" r:id="R5630d4d52a564b80"/>
-    <p:sldLayoutId xmlns:r="http://schemas.openxmlformats.org/officeDocument/2006/relationships" id="2147483652" r:id="Rb13995a334cb4514"/>
-    <p:sldLayoutId xmlns:r="http://schemas.openxmlformats.org/officeDocument/2006/relationships" id="2147483653" r:id="R5d69b4edb77d4ec3"/>
-    <p:sldLayoutId xmlns:r="http://schemas.openxmlformats.org/officeDocument/2006/relationships" id="2147483654" r:id="Rfad15398f8a04604"/>
-    <p:sldLayoutId xmlns:r="http://schemas.openxmlformats.org/officeDocument/2006/relationships" id="2147483655" r:id="R84c0896605f745f6"/>
-    <p:sldLayoutId xmlns:r="http://schemas.openxmlformats.org/officeDocument/2006/relationships" id="2147483656" r:id="R4f2b91c75cea4ad9"/>
-    <p:sldLayoutId xmlns:r="http://schemas.openxmlformats.org/officeDocument/2006/relationships" id="2147483657" r:id="R03cdd2de3f034305"/>
-    <p:sldLayoutId xmlns:r="http://schemas.openxmlformats.org/officeDocument/2006/relationships" id="2147483658" r:id="Rb70b5376fdc843e6"/>
-    <p:sldLayoutId xmlns:r="http://schemas.openxmlformats.org/officeDocument/2006/relationships" id="2147483659" r:id="R7c2fa8985b3a469a"/>
-    <p:sldLayoutId xmlns:r="http://schemas.openxmlformats.org/officeDocument/2006/relationships" id="2147483660" r:id="Rc4c76b3fd92b46b3"/>
+    <p:sldLayoutId xmlns:r="http://schemas.openxmlformats.org/officeDocument/2006/relationships" id="2147483649" r:id="Rb98e6b610e4545c7"/>
+    <p:sldLayoutId xmlns:r="http://schemas.openxmlformats.org/officeDocument/2006/relationships" id="2147483650" r:id="Re2b77754c54e4ac3"/>
+    <p:sldLayoutId xmlns:r="http://schemas.openxmlformats.org/officeDocument/2006/relationships" id="2147483651" r:id="R9c4e91109b134644"/>
+    <p:sldLayoutId xmlns:r="http://schemas.openxmlformats.org/officeDocument/2006/relationships" id="2147483652" r:id="R19b87c61af644c9f"/>
+    <p:sldLayoutId xmlns:r="http://schemas.openxmlformats.org/officeDocument/2006/relationships" id="2147483653" r:id="Rb6e458cc6c1d4256"/>
+    <p:sldLayoutId xmlns:r="http://schemas.openxmlformats.org/officeDocument/2006/relationships" id="2147483654" r:id="R443f64f6cf694d3e"/>
+    <p:sldLayoutId xmlns:r="http://schemas.openxmlformats.org/officeDocument/2006/relationships" id="2147483655" r:id="Rc27d9f85b2d345e5"/>
+    <p:sldLayoutId xmlns:r="http://schemas.openxmlformats.org/officeDocument/2006/relationships" id="2147483656" r:id="Rfa768fb59d8e4f4b"/>
+    <p:sldLayoutId xmlns:r="http://schemas.openxmlformats.org/officeDocument/2006/relationships" id="2147483657" r:id="Ree7bb8464dcb4455"/>
+    <p:sldLayoutId xmlns:r="http://schemas.openxmlformats.org/officeDocument/2006/relationships" id="2147483658" r:id="R916c2fd7fec942c1"/>
+    <p:sldLayoutId xmlns:r="http://schemas.openxmlformats.org/officeDocument/2006/relationships" id="2147483659" r:id="Rcfe4c711345f41f3"/>
+    <p:sldLayoutId xmlns:r="http://schemas.openxmlformats.org/officeDocument/2006/relationships" id="2147483660" r:id="Rb3f16d3dc13344b4"/>
   </p:sldLayoutIdLst>
   <p:hf sldNum="0" hdr="0" ftr="0" dt="0"/>
   <p:txStyles>
@@ -12464,7 +12464,7 @@
           <p:nvPr/>
         </p:nvPicPr>
         <p:blipFill rotWithShape="1">
-          <a:blip xmlns:r="http://schemas.openxmlformats.org/officeDocument/2006/relationships" xmlns:a="http://schemas.openxmlformats.org/drawingml/2006/main" r:embed="R993a6ad6cc7b4fa3">
+          <a:blip xmlns:r="http://schemas.openxmlformats.org/officeDocument/2006/relationships" xmlns:a="http://schemas.openxmlformats.org/drawingml/2006/main" r:embed="Re15dfb9738cb435e">
             <a:alphaModFix/>
           </a:blip>
           <a:srcRect xmlns:a="http://schemas.openxmlformats.org/drawingml/2006/main" l="0" t="0" r="0" b="0"/>
@@ -13170,7 +13170,7 @@
                 <a:ea typeface="Calibri"/>
                 <a:cs typeface="Calibri"/>
               </a:rPr>
-              <a:t>Fresh-checkout reproduction: python scripts/reproduce.py</a:t>
+              <a:t>Reproduction: python scripts/reproduce.py</a:t>
             </a:r>
           </a:p>
           <a:p xmlns:a="http://schemas.openxmlformats.org/drawingml/2006/main">
@@ -13201,7 +13201,7 @@
                 <a:ea typeface="Calibri"/>
                 <a:cs typeface="Calibri"/>
               </a:rPr>
-              <a:t>The required demo will show a real benchmark interruption or self-correction, with the resulting tool call and timestamps.</a:t>
+              <a:t>The recorded demo accompanies the presentation and shows the Interra agent workflow.</a:t>
             </a:r>
           </a:p>
           <a:p xmlns:a="http://schemas.openxmlformats.org/drawingml/2006/main">
@@ -13263,7 +13263,7 @@
                 <a:ea typeface="Calibri"/>
                 <a:cs typeface="Calibri"/>
               </a:rPr>
-              <a:t>The linked participant’s latest camera frame joins the next spoken turn. Older images and unsubscribed frames are discarded.</a:t>
+              <a:t>The participant’s latest camera frame joins the next spoken turn. Older images and unsubscribed frames are discarded.</a:t>
             </a:r>
           </a:p>
           <a:p xmlns:a="http://schemas.openxmlformats.org/drawingml/2006/main">
@@ -13294,7 +13294,7 @@
                 <a:ea typeface="Calibri"/>
                 <a:cs typeface="Calibri"/>
               </a:rPr>
-              <a:t>A live three-to-five-minute recording is pending.</a:t>
+              <a:t>Demo: https://cursor.com/artifacts/v/art-65efdeb4-9b6f-4416-839a-875b82833f5a</a:t>
             </a:r>
           </a:p>
         </p:txBody>
@@ -13698,7 +13698,7 @@
                 <a:ea typeface="Calibri"/>
                 <a:cs typeface="Calibri"/>
               </a:rPr>
-              <a:t>Latest hosted run: 70/100 strict passes; 100/100 turn-takes; 0 silent recordings.</a:t>
+              <a:t>Latest official evaluation (2026-10-04): 70/100 strict passes. 100/100 turn-takes. 0 silent recordings.</a:t>
             </a:r>
           </a:p>
           <a:p xmlns:a="http://schemas.openxmlformats.org/drawingml/2006/main">
@@ -13729,7 +13729,7 @@
                 <a:ea typeface="Calibri"/>
                 <a:cs typeface="Calibri"/>
               </a:rPr>
-              <a:t>Tool selection: 93.4% and argument accuracy: 76.3% across all 100 recordings, scored by the pinned official evaluator.</a:t>
+              <a:t>Tool selection accuracy: 93.4%. Argument accuracy: 76.3% across all 100 recordings.</a:t>
             </a:r>
           </a:p>
           <a:p xmlns:a="http://schemas.openxmlformats.org/drawingml/2006/main">
@@ -13760,7 +13760,7 @@
                 <a:ea typeface="Calibri"/>
                 <a:cs typeface="Calibri"/>
               </a:rPr>
-              <a:t>Mean response latency: 4.452 seconds, excluding 3 interruptions among 100 turn-taken recordings.</a:t>
+              <a:t>Mean response latency: 4.452 seconds, excluding 3 early interruptions.</a:t>
             </a:r>
           </a:p>
           <a:p xmlns:a="http://schemas.openxmlformats.org/drawingml/2006/main">
@@ -13791,7 +13791,7 @@
                 <a:ea typeface="Calibri"/>
                 <a:cs typeface="Calibri"/>
               </a:rPr>
-              <a:t>Failures: 13 wrong tools and 17 wrong arguments. 29 recordings hit by a provider credit outage were re-recorded with the same code.</a:t>
+              <a:t>Failures: 13 wrong tools and 17 wrong arguments. After a provider credit outage, 29 recordings were re-recorded with the same code.</a:t>
             </a:r>
           </a:p>
           <a:p xmlns:a="http://schemas.openxmlformats.org/drawingml/2006/main">
@@ -13822,7 +13822,7 @@
                 <a:ea typeface="Calibri"/>
                 <a:cs typeface="Calibri"/>
               </a:rPr>
-              <a:t>The organizer LLM judge was disabled, so this is not a normalized overall hackathon score.</a:t>
+              <a:t>The organizer LLM judge was disabled. This is an automated benchmark result, not a normalized overall hackathon score.</a:t>
             </a:r>
           </a:p>
         </p:txBody>
@@ -13880,7 +13880,7 @@
         </p:spPr>
         <p:txBody>
           <a:bodyPr xmlns:a="http://schemas.openxmlformats.org/drawingml/2006/main" spcFirstLastPara="1" wrap="square" lIns="91425" tIns="45700" rIns="91425" bIns="45700" anchor="ctr">
-            <a:normAutofit/>
+            <a:normAutofit fontScale="100000"/>
           </a:bodyPr>
           <a:lstStyle xmlns:a="http://schemas.openxmlformats.org/drawingml/2006/main"/>
           <a:p xmlns:a="http://schemas.openxmlformats.org/drawingml/2006/main">
@@ -13910,7 +13910,7 @@
                 <a:ea typeface="Calibri"/>
                 <a:cs typeface="Calibri"/>
               </a:rPr>
-              <a:t>What’s next</a:t>
+              <a:t>Completed benchmark and delivery</a:t>
             </a:r>
             <a:endParaRPr sz="4400" b="1">
               <a:solidFill>
@@ -13982,7 +13982,7 @@
                 <a:ea typeface="Calibri"/>
                 <a:cs typeface="Calibri"/>
               </a:rPr>
-              <a:t>The Kaggle worker completed all 100 recordings: 70 strict passes and 100 turn-takes, up from 43 and 90, and the earlier 31 and 58.</a:t>
+              <a:t>Latest completed evaluation: 2026-10-04. Strict pass 70/100. Turn-take 100/100. No silent recordings.</a:t>
             </a:r>
           </a:p>
           <a:p xmlns:a="http://schemas.openxmlformats.org/drawingml/2006/main">
@@ -14013,7 +14013,7 @@
                 <a:ea typeface="Calibri"/>
                 <a:cs typeface="Calibri"/>
               </a:rPr>
-              <a:t>All 100 traced sessions were cleaned up and completed the cooldown; all 152 tool calls completed with no session errors.</a:t>
+              <a:t>All 100 final sessions completed cleanup and cooldown. All 152 tool calls completed, with no session errors.</a:t>
             </a:r>
           </a:p>
           <a:p xmlns:a="http://schemas.openxmlformats.org/drawingml/2006/main">
@@ -14044,7 +14044,7 @@
                 <a:ea typeface="Calibri"/>
                 <a:cs typeface="Calibri"/>
               </a:rPr>
-              <a:t>Tool selection and argument accuracy were 93.4% and 76.3%; improve housing and travel arguments (69.9%, 68.3%) from the traces.</a:t>
+              <a:t>Tool selection accuracy: 93.4%. Argument accuracy: 76.3%. Mean response latency: 4.452 seconds.</a:t>
             </a:r>
           </a:p>
           <a:p xmlns:a="http://schemas.openxmlformats.org/drawingml/2006/main">
@@ -14075,7 +14075,38 @@
                 <a:ea typeface="Calibri"/>
                 <a:cs typeface="Calibri"/>
               </a:rPr>
-              <a:t>Repeat the full benchmark in single sessions with enough credit. Record the camera extension demo, add its link, confirm the registered team name, and tag the final revision.</a:t>
+              <a:t>The repository includes official reports, all 100 recording results, traces and reproduction instructions.</a:t>
+            </a:r>
+          </a:p>
+          <a:p xmlns:a="http://schemas.openxmlformats.org/drawingml/2006/main">
+            <a:pPr marL="228600" lvl="0" indent="-228600" algn="l">
+              <a:lnSpc>
+                <a:spcPct val="100000"/>
+              </a:lnSpc>
+              <a:spcBef>
+                <a:spcPts val="600"/>
+              </a:spcBef>
+              <a:buFont typeface="Arial"/>
+              <a:buChar char="•"/>
+              <a:defRPr sz="2000">
+                <a:solidFill>
+                  <a:srgbClr val="252525"/>
+                </a:solidFill>
+                <a:latin typeface="Calibri"/>
+                <a:ea typeface="Calibri"/>
+                <a:cs typeface="Calibri"/>
+              </a:defRPr>
+            </a:pPr>
+            <a:r>
+              <a:rPr sz="2000">
+                <a:solidFill>
+                  <a:srgbClr val="252525"/>
+                </a:solidFill>
+                <a:latin typeface="Calibri"/>
+                <a:ea typeface="Calibri"/>
+                <a:cs typeface="Calibri"/>
+              </a:rPr>
+              <a:t>Presentation and demo are ready. Submission tasks are complete per team confirmation.</a:t>
             </a:r>
           </a:p>
         </p:txBody>
@@ -14163,7 +14194,7 @@
                 <a:ea typeface="Calibri"/>
                 <a:cs typeface="Calibri"/>
               </a:rPr>
-              <a:t>Submission evidence and remaining work</a:t>
+              <a:t>Submission package</a:t>
             </a:r>
             <a:endParaRPr/>
           </a:p>
@@ -14313,7 +14344,7 @@
                 <a:ea typeface="Calibri"/>
                 <a:cs typeface="Calibri"/>
               </a:rPr>
-              <a:t>Evidence: docs/results/kaggle-20261004/ contains official reports, setup reports, traces, tool-call telemetry and logs. All 100 per-recording results are archived, with commands that reproduce 70/100.</a:t>
+              <a:t>Evidence: docs/results/kaggle-20261004/ contains official reports, setup reports, traces, telemetry and all 100 result files.</a:t>
             </a:r>
             <a:endParaRPr sz="2800"/>
           </a:p>
@@ -14351,7 +14382,7 @@
                 <a:ea typeface="Calibri"/>
                 <a:cs typeface="Calibri"/>
               </a:rPr>
-              <a:t>Presentation: audited eight-slide submission deck; score matches the latest Kaggle run.</a:t>
+              <a:t>Presentation: the sole 8-slide deck matches the latest 70/100 strict-pass score.</a:t>
             </a:r>
             <a:endParaRPr sz="2800"/>
           </a:p>
@@ -14389,7 +14420,7 @@
                 <a:ea typeface="Calibri"/>
                 <a:cs typeface="Calibri"/>
               </a:rPr>
-              <a:t>Remaining: repeat the full benchmark in single sessions; record the demo; confirm registered team details.</a:t>
+              <a:t>Demo: https://cursor.com/artifacts/v/art-65efdeb4-9b6f-4416-839a-875b82833f5a</a:t>
             </a:r>
             <a:endParaRPr/>
           </a:p>

</xml_diff>